<commit_message>
Minor updates to W4 (flat data upload)
</commit_message>
<xml_diff>
--- a/Lectures/Lecture 02.2 - R.pptx
+++ b/Lectures/Lecture 02.2 - R.pptx
@@ -484,7 +484,7 @@
           <a:p>
             <a:fld id="{494CC62B-EE64-493C-ACFA-F64AA6808250}" type="datetimeFigureOut">
               <a:rPr lang="en-GB" smtClean="0"/>
-              <a:t>04/07/2024</a:t>
+              <a:t>18/08/2024</a:t>
             </a:fld>
             <a:endParaRPr lang="en-GB"/>
           </a:p>
@@ -694,7 +694,7 @@
           <a:p>
             <a:fld id="{494CC62B-EE64-493C-ACFA-F64AA6808250}" type="datetimeFigureOut">
               <a:rPr lang="en-GB" smtClean="0"/>
-              <a:t>04/07/2024</a:t>
+              <a:t>18/08/2024</a:t>
             </a:fld>
             <a:endParaRPr lang="en-GB"/>
           </a:p>
@@ -916,7 +916,7 @@
           <a:p>
             <a:fld id="{494CC62B-EE64-493C-ACFA-F64AA6808250}" type="datetimeFigureOut">
               <a:rPr lang="en-GB" smtClean="0"/>
-              <a:t>04/07/2024</a:t>
+              <a:t>18/08/2024</a:t>
             </a:fld>
             <a:endParaRPr lang="en-GB"/>
           </a:p>
@@ -1116,7 +1116,7 @@
           <a:p>
             <a:fld id="{6AF2DC2B-FEE6-469D-B9B0-5A8256869BC2}" type="datetimeFigureOut">
               <a:rPr lang="en-GB" smtClean="0"/>
-              <a:t>04/07/2024</a:t>
+              <a:t>18/08/2024</a:t>
             </a:fld>
             <a:endParaRPr lang="en-GB"/>
           </a:p>
@@ -2055,7 +2055,7 @@
           <a:p>
             <a:fld id="{494CC62B-EE64-493C-ACFA-F64AA6808250}" type="datetimeFigureOut">
               <a:rPr lang="en-GB" smtClean="0"/>
-              <a:t>04/07/2024</a:t>
+              <a:t>18/08/2024</a:t>
             </a:fld>
             <a:endParaRPr lang="en-GB"/>
           </a:p>
@@ -2197,7 +2197,7 @@
           <a:p>
             <a:fld id="{494CC62B-EE64-493C-ACFA-F64AA6808250}" type="datetimeFigureOut">
               <a:rPr lang="en-GB" smtClean="0"/>
-              <a:t>04/07/2024</a:t>
+              <a:t>18/08/2024</a:t>
             </a:fld>
             <a:endParaRPr lang="en-GB"/>
           </a:p>
@@ -2310,7 +2310,7 @@
           <a:p>
             <a:fld id="{494CC62B-EE64-493C-ACFA-F64AA6808250}" type="datetimeFigureOut">
               <a:rPr lang="en-GB" smtClean="0"/>
-              <a:t>04/07/2024</a:t>
+              <a:t>18/08/2024</a:t>
             </a:fld>
             <a:endParaRPr lang="en-GB"/>
           </a:p>
@@ -2623,7 +2623,7 @@
           <a:p>
             <a:fld id="{494CC62B-EE64-493C-ACFA-F64AA6808250}" type="datetimeFigureOut">
               <a:rPr lang="en-GB" smtClean="0"/>
-              <a:t>04/07/2024</a:t>
+              <a:t>18/08/2024</a:t>
             </a:fld>
             <a:endParaRPr lang="en-GB"/>
           </a:p>
@@ -2916,7 +2916,7 @@
           <a:p>
             <a:fld id="{494CC62B-EE64-493C-ACFA-F64AA6808250}" type="datetimeFigureOut">
               <a:rPr lang="en-GB" smtClean="0"/>
-              <a:t>04/07/2024</a:t>
+              <a:t>18/08/2024</a:t>
             </a:fld>
             <a:endParaRPr lang="en-GB"/>
           </a:p>
@@ -3159,7 +3159,7 @@
           <a:p>
             <a:fld id="{494CC62B-EE64-493C-ACFA-F64AA6808250}" type="datetimeFigureOut">
               <a:rPr lang="en-GB" smtClean="0"/>
-              <a:t>04/07/2024</a:t>
+              <a:t>18/08/2024</a:t>
             </a:fld>
             <a:endParaRPr lang="en-GB"/>
           </a:p>
@@ -7926,68 +7926,6 @@
           </p:style>
         </p:cxnSp>
       </p:grpSp>
-      <p:sp>
-        <p:nvSpPr>
-          <p:cNvPr id="14" name="Google Shape;57;p13">
-            <a:extLst>
-              <a:ext uri="{FF2B5EF4-FFF2-40B4-BE49-F238E27FC236}">
-                <a16:creationId xmlns:a16="http://schemas.microsoft.com/office/drawing/2014/main" id="{B70B7BA8-F528-4807-BE50-FC25C85B5D4C}"/>
-              </a:ext>
-            </a:extLst>
-          </p:cNvPr>
-          <p:cNvSpPr/>
-          <p:nvPr/>
-        </p:nvSpPr>
-        <p:spPr>
-          <a:xfrm>
-            <a:off x="4695902" y="1132628"/>
-            <a:ext cx="2622625" cy="105225"/>
-          </a:xfrm>
-          <a:custGeom>
-            <a:avLst/>
-            <a:gdLst/>
-            <a:ahLst/>
-            <a:cxnLst/>
-            <a:rect l="l" t="t" r="r" b="b"/>
-            <a:pathLst>
-              <a:path w="104905" h="4209" extrusionOk="0">
-                <a:moveTo>
-                  <a:pt x="0" y="2010"/>
-                </a:moveTo>
-                <a:cubicBezTo>
-                  <a:pt x="34411" y="-4246"/>
-                  <a:pt x="71725" y="11060"/>
-                  <a:pt x="104905" y="0"/>
-                </a:cubicBezTo>
-              </a:path>
-            </a:pathLst>
-          </a:custGeom>
-          <a:noFill/>
-          <a:ln w="19050" cap="flat" cmpd="sng">
-            <a:solidFill>
-              <a:srgbClr val="4C1130"/>
-            </a:solidFill>
-            <a:prstDash val="solid"/>
-            <a:round/>
-            <a:headEnd type="none" w="med" len="med"/>
-            <a:tailEnd type="none" w="med" len="med"/>
-          </a:ln>
-          <a:effectLst>
-            <a:outerShdw blurRad="57150" dist="19050" dir="5400000" algn="bl" rotWithShape="0">
-              <a:srgbClr val="000000">
-                <a:alpha val="50000"/>
-              </a:srgbClr>
-            </a:outerShdw>
-          </a:effectLst>
-        </p:spPr>
-        <p:txBody>
-          <a:bodyPr/>
-          <a:lstStyle/>
-          <a:p>
-            <a:endParaRPr lang="en-GB"/>
-          </a:p>
-        </p:txBody>
-      </p:sp>
     </p:spTree>
     <p:extLst>
       <p:ext uri="{BB962C8B-B14F-4D97-AF65-F5344CB8AC3E}">
@@ -18889,68 +18827,6 @@
           </a:p>
         </p:txBody>
       </p:sp>
-      <p:sp>
-        <p:nvSpPr>
-          <p:cNvPr id="4" name="Google Shape;57;p13">
-            <a:extLst>
-              <a:ext uri="{FF2B5EF4-FFF2-40B4-BE49-F238E27FC236}">
-                <a16:creationId xmlns:a16="http://schemas.microsoft.com/office/drawing/2014/main" id="{51433392-351B-4BC6-A2A6-B11E9F2AE918}"/>
-              </a:ext>
-            </a:extLst>
-          </p:cNvPr>
-          <p:cNvSpPr/>
-          <p:nvPr/>
-        </p:nvSpPr>
-        <p:spPr>
-          <a:xfrm>
-            <a:off x="4695902" y="1295188"/>
-            <a:ext cx="2622625" cy="105225"/>
-          </a:xfrm>
-          <a:custGeom>
-            <a:avLst/>
-            <a:gdLst/>
-            <a:ahLst/>
-            <a:cxnLst/>
-            <a:rect l="l" t="t" r="r" b="b"/>
-            <a:pathLst>
-              <a:path w="104905" h="4209" extrusionOk="0">
-                <a:moveTo>
-                  <a:pt x="0" y="2010"/>
-                </a:moveTo>
-                <a:cubicBezTo>
-                  <a:pt x="34411" y="-4246"/>
-                  <a:pt x="71725" y="11060"/>
-                  <a:pt x="104905" y="0"/>
-                </a:cubicBezTo>
-              </a:path>
-            </a:pathLst>
-          </a:custGeom>
-          <a:noFill/>
-          <a:ln w="19050" cap="flat" cmpd="sng">
-            <a:solidFill>
-              <a:srgbClr val="4C1130"/>
-            </a:solidFill>
-            <a:prstDash val="solid"/>
-            <a:round/>
-            <a:headEnd type="none" w="med" len="med"/>
-            <a:tailEnd type="none" w="med" len="med"/>
-          </a:ln>
-          <a:effectLst>
-            <a:outerShdw blurRad="57150" dist="19050" dir="5400000" algn="bl" rotWithShape="0">
-              <a:srgbClr val="000000">
-                <a:alpha val="50000"/>
-              </a:srgbClr>
-            </a:outerShdw>
-          </a:effectLst>
-        </p:spPr>
-        <p:txBody>
-          <a:bodyPr/>
-          <a:lstStyle/>
-          <a:p>
-            <a:endParaRPr lang="en-GB"/>
-          </a:p>
-        </p:txBody>
-      </p:sp>
       <p:pic>
         <p:nvPicPr>
           <p:cNvPr id="8" name="Picture 7">

</xml_diff>